<commit_message>
Presentation: add three website slides with live screenshots of the real pilot (14 slides)
Watchlist and trends, drill-down and brief, audit trail / drift / model registry / API.
Drift page wording now covers quarterly windows.
</commit_message>
<xml_diff>
--- a/presentation/Sentari_Presentation.pptx
+++ b/presentation/Sentari_Presentation.pptx
@@ -19,6 +19,8 @@
     <p:sldId id="286" r:id="rId30"/>
     <p:sldId id="287" r:id="rId31"/>
     <p:sldId id="288" r:id="rId32"/>
+    <p:sldId id="289" r:id="rId33"/>
+    <p:sldId id="290" r:id="rId34"/>
     <p:sldId id="272" r:id="rId14"/>
   </p:sldIdLst>
   <p:sldSz cx="9144000" cy="6858000" type="screen4x3"/>
@@ -1454,7 +1456,7 @@
           <a:lstStyle/>
           <a:p>
             <a:r>
-              <a:t>Research and decision-support only; nothing here is investment advice or a trading signal.</a:t>
+              <a:t>Audit trail: every agent step is stored per brief - here the Skeptic's per-claim checks (citation, numbers, similarity, overlap, NLI entailment 0.978). Drift is measured per company on quarterly windows.</a:t>
             </a:r>
           </a:p>
         </p:txBody>
@@ -1524,7 +1526,7 @@
           <a:lstStyle/>
           <a:p>
             <a:r>
-              <a:t>Full citations and tool versions are in the project repository README and requirements.</a:t>
+              <a:t>Pilot data: kurry/sp500_earnings_transcripts (Hugging Face, pinned revision). Scores: lm_directional and finbert_ft. Study is PRELIMINARY until the human-labelled real gold set picks the model. Bonferroni over 6 tests: no Q&amp;A-gap coefficient survives. Source: results/pilot/signal_validity_preliminary.json</a:t>
             </a:r>
           </a:p>
         </p:txBody>
@@ -1594,6 +1596,146 @@
           <a:lstStyle/>
           <a:p>
             <a:r>
+              <a:t>Research and decision-support only; nothing here is investment advice or a trading signal.</a:t>
+            </a:r>
+          </a:p>
+        </p:txBody>
+      </p:sp>
+      <p:sp>
+        <p:nvSpPr>
+          <p:cNvPr id="4" name="Slide Number Placeholder 3"/>
+          <p:cNvSpPr>
+            <a:spLocks noGrp="1"/>
+          </p:cNvSpPr>
+          <p:nvPr>
+            <p:ph type="sldNum" idx="5" sz="quarter"/>
+          </p:nvPr>
+        </p:nvSpPr>
+        <p:spPr/>
+      </p:sp>
+    </p:spTree>
+  </p:cSld>
+  <p:clrMapOvr>
+    <a:masterClrMapping/>
+  </p:clrMapOvr>
+</p:notes>
+</file>
+
+<file path=ppt/notesSlides/notesSlide13.xml><?xml version="1.0" encoding="utf-8"?>
+<p:notes xmlns:a="http://schemas.openxmlformats.org/drawingml/2006/main" xmlns:p="http://schemas.openxmlformats.org/presentationml/2006/main" xmlns:r="http://schemas.openxmlformats.org/officeDocument/2006/relationships">
+  <p:cSld>
+    <p:spTree>
+      <p:nvGrpSpPr>
+        <p:cNvPr id="1" name=""/>
+        <p:cNvGrpSpPr/>
+        <p:nvPr/>
+      </p:nvGrpSpPr>
+      <p:grpSpPr>
+        <a:xfrm>
+          <a:off x="0" y="0"/>
+          <a:ext cx="0" cy="0"/>
+          <a:chOff x="0" y="0"/>
+          <a:chExt cx="0" cy="0"/>
+        </a:xfrm>
+      </p:grpSpPr>
+      <p:sp>
+        <p:nvSpPr>
+          <p:cNvPr id="2" name="Slide Image Placeholder 1"/>
+          <p:cNvSpPr>
+            <a:spLocks noGrp="1"/>
+          </p:cNvSpPr>
+          <p:nvPr>
+            <p:ph type="sldImg" idx="2"/>
+          </p:nvPr>
+        </p:nvSpPr>
+        <p:spPr/>
+      </p:sp>
+      <p:sp>
+        <p:nvSpPr>
+          <p:cNvPr id="3" name="Notes Placeholder 2"/>
+          <p:cNvSpPr>
+            <a:spLocks noGrp="1"/>
+          </p:cNvSpPr>
+          <p:nvPr>
+            <p:ph type="body" idx="3" sz="quarter"/>
+          </p:nvPr>
+        </p:nvSpPr>
+        <p:spPr/>
+        <p:txBody>
+          <a:bodyPr/>
+          <a:lstStyle/>
+          <a:p>
+            <a:r>
+              <a:t>Full citations and tool versions are in the project repository README and requirements.</a:t>
+            </a:r>
+          </a:p>
+        </p:txBody>
+      </p:sp>
+      <p:sp>
+        <p:nvSpPr>
+          <p:cNvPr id="4" name="Slide Number Placeholder 3"/>
+          <p:cNvSpPr>
+            <a:spLocks noGrp="1"/>
+          </p:cNvSpPr>
+          <p:nvPr>
+            <p:ph type="sldNum" idx="5" sz="quarter"/>
+          </p:nvPr>
+        </p:nvSpPr>
+        <p:spPr/>
+      </p:sp>
+    </p:spTree>
+  </p:cSld>
+  <p:clrMapOvr>
+    <a:masterClrMapping/>
+  </p:clrMapOvr>
+</p:notes>
+</file>
+
+<file path=ppt/notesSlides/notesSlide14.xml><?xml version="1.0" encoding="utf-8"?>
+<p:notes xmlns:a="http://schemas.openxmlformats.org/drawingml/2006/main" xmlns:p="http://schemas.openxmlformats.org/presentationml/2006/main" xmlns:r="http://schemas.openxmlformats.org/officeDocument/2006/relationships">
+  <p:cSld>
+    <p:spTree>
+      <p:nvGrpSpPr>
+        <p:cNvPr id="1" name=""/>
+        <p:cNvGrpSpPr/>
+        <p:nvPr/>
+      </p:nvGrpSpPr>
+      <p:grpSpPr>
+        <a:xfrm>
+          <a:off x="0" y="0"/>
+          <a:ext cx="0" cy="0"/>
+          <a:chOff x="0" y="0"/>
+          <a:chExt cx="0" cy="0"/>
+        </a:xfrm>
+      </p:grpSpPr>
+      <p:sp>
+        <p:nvSpPr>
+          <p:cNvPr id="2" name="Slide Image Placeholder 1"/>
+          <p:cNvSpPr>
+            <a:spLocks noGrp="1"/>
+          </p:cNvSpPr>
+          <p:nvPr>
+            <p:ph type="sldImg" idx="2"/>
+          </p:nvPr>
+        </p:nvSpPr>
+        <p:spPr/>
+      </p:sp>
+      <p:sp>
+        <p:nvSpPr>
+          <p:cNvPr id="3" name="Notes Placeholder 2"/>
+          <p:cNvSpPr>
+            <a:spLocks noGrp="1"/>
+          </p:cNvSpPr>
+          <p:nvPr>
+            <p:ph type="body" idx="3" sz="quarter"/>
+          </p:nvPr>
+        </p:nvSpPr>
+        <p:spPr/>
+        <p:txBody>
+          <a:bodyPr/>
+          <a:lstStyle/>
+          <a:p>
+            <a:r>
               <a:t>Questions.</a:t>
             </a:r>
           </a:p>
@@ -2084,7 +2226,7 @@
           <a:lstStyle/>
           <a:p>
             <a:r>
-              <a:t>Screenshots from the real 10-company pilot (not the synthetic demo data). Next.js 16 dashboard over the FastAPI read API; dark mode and phone widths supported.</a:t>
+              <a:t>Live screenshots of the Next.js dashboard running on the real pilot database (414 calls). Every page carries the not-investment-advice notice.</a:t>
             </a:r>
           </a:p>
         </p:txBody>
@@ -2154,7 +2296,7 @@
           <a:lstStyle/>
           <a:p>
             <a:r>
-              <a:t>Pilot data: kurry/sp500_earnings_transcripts (Hugging Face, pinned revision). Scores: lm_directional and finbert_ft. Study is PRELIMINARY until the human-labelled real gold set picks the model. Bonferroni over 6 tests: no Q&amp;A-gap coefficient survives. Source: results/pilot/signal_validity_preliminary.json</a:t>
+              <a:t>Drill-down example: Boeing liquidity, Q4 2024 call. The brief uses the latest call plus the one before; only claims the Skeptic marks supported appear.</a:t>
             </a:r>
           </a:p>
         </p:txBody>
@@ -9561,7 +9703,7 @@
             </a:pPr>
             <a:r>
               <a:rPr spc="-10" dirty="0"/>
-              <a:t>DASHBOARD ON REAL DATA</a:t>
+              <a:t>WEBSITE: WATCHLIST &amp; TRENDS</a:t>
             </a:r>
             <a:endParaRPr spc="-10" dirty="0"/>
           </a:p>
@@ -9645,7 +9787,7 @@
       </p:sp>
       <p:pic>
         <p:nvPicPr>
-          <p:cNvPr id="10" name="Picture 9" descr="pilot_ba_trajectories_crop.png"/>
+          <p:cNvPr id="10" name="Picture 9" descr="pilot_watchlist_crop.png"/>
           <p:cNvPicPr>
             <a:picLocks noChangeAspect="1"/>
           </p:cNvPicPr>
@@ -9660,7 +9802,7 @@
         <p:spPr>
           <a:xfrm>
             <a:off x="411480" y="1298448"/>
-            <a:ext cx="4069080" cy="2134395"/>
+            <a:ext cx="4069080" cy="2810138"/>
           </a:xfrm>
           <a:prstGeom prst="rect">
             <a:avLst/>
@@ -9672,48 +9814,9 @@
           </a:ln>
         </p:spPr>
       </p:pic>
-      <p:sp>
-        <p:nvSpPr>
-          <p:cNvPr id="11" name="TextBox 10"/>
-          <p:cNvSpPr txBox="1"/>
-          <p:nvPr/>
-        </p:nvSpPr>
-        <p:spPr>
-          <a:xfrm>
-            <a:off x="411480" y="3520440"/>
-            <a:ext cx="4069080" cy="411480"/>
-          </a:xfrm>
-          <a:prstGeom prst="rect">
-            <a:avLst/>
-          </a:prstGeom>
-          <a:noFill/>
-        </p:spPr>
-        <p:txBody>
-          <a:bodyPr wrap="square" lIns="36576" rIns="36576" tIns="18288" bIns="18288" anchor="t">
-            <a:spAutoFit/>
-          </a:bodyPr>
-          <a:lstStyle/>
-          <a:p>
-            <a:pPr algn="ctr">
-              <a:spcAft>
-                <a:spcPts val="400"/>
-              </a:spcAft>
-            </a:pPr>
-            <a:r>
-              <a:rPr sz="1100" b="0" i="0">
-                <a:solidFill>
-                  <a:srgbClr val="595959"/>
-                </a:solidFill>
-                <a:latin typeface="Times New Roman"/>
-              </a:rPr>
-              <a:t>Six aspect trajectories for Boeing, 2015–2025 (prepared vs Q&amp;A lines)</a:t>
-            </a:r>
-          </a:p>
-        </p:txBody>
-      </p:sp>
       <p:pic>
         <p:nvPicPr>
-          <p:cNvPr id="12" name="Picture 11" descr="pilot_ba_brief_crop.png"/>
+          <p:cNvPr id="11" name="Picture 10" descr="pilot_ba_trajectories_crop.png"/>
           <p:cNvPicPr>
             <a:picLocks noChangeAspect="1"/>
           </p:cNvPicPr>
@@ -9727,8 +9830,8 @@
         </p:blipFill>
         <p:spPr>
           <a:xfrm>
-            <a:off x="4636008" y="1298448"/>
-            <a:ext cx="4069080" cy="2134395"/>
+            <a:off x="4663440" y="1298448"/>
+            <a:ext cx="4069080" cy="2810138"/>
           </a:xfrm>
           <a:prstGeom prst="rect">
             <a:avLst/>
@@ -9742,14 +9845,14 @@
       </p:pic>
       <p:sp>
         <p:nvSpPr>
-          <p:cNvPr id="13" name="TextBox 12"/>
+          <p:cNvPr id="12" name="TextBox 11"/>
           <p:cNvSpPr txBox="1"/>
           <p:nvPr/>
         </p:nvSpPr>
         <p:spPr>
           <a:xfrm>
-            <a:off x="4636008" y="3520440"/>
-            <a:ext cx="4069080" cy="411480"/>
+            <a:off x="411480" y="4181738"/>
+            <a:ext cx="4069080" cy="310896"/>
           </a:xfrm>
           <a:prstGeom prst="rect">
             <a:avLst/>
@@ -9762,220 +9865,230 @@
           </a:bodyPr>
           <a:lstStyle/>
           <a:p>
-            <a:pPr algn="ctr">
+            <a:pPr algn="l">
               <a:spcAft>
                 <a:spcPts val="400"/>
               </a:spcAft>
             </a:pPr>
             <a:r>
-              <a:rPr sz="1100" b="0" i="0">
-                <a:solidFill>
-                  <a:srgbClr val="595959"/>
+              <a:rPr sz="1300" b="1" i="0">
+                <a:solidFill>
+                  <a:srgbClr val="9F1C33"/>
                 </a:solidFill>
                 <a:latin typeface="Times New Roman"/>
               </a:rPr>
-              <a:t>Boeing brief (Oct 2024 – Apr 2025): every claim links to its source</a:t>
-            </a:r>
-          </a:p>
-        </p:txBody>
-      </p:sp>
-      <p:sp>
-        <p:nvSpPr>
-          <p:cNvPr id="14" name="Rounded Rectangle 13"/>
-          <p:cNvSpPr/>
-          <p:nvPr/>
-        </p:nvSpPr>
-        <p:spPr>
-          <a:xfrm>
-            <a:off x="411480" y="4160520"/>
-            <a:ext cx="2697480" cy="1005840"/>
-          </a:xfrm>
-          <a:prstGeom prst="roundRect">
-            <a:avLst>
-              <a:gd name="adj" fmla="val 8000"/>
-            </a:avLst>
-          </a:prstGeom>
-          <a:solidFill>
-            <a:srgbClr val="F6E4E7"/>
-          </a:solidFill>
-          <a:ln>
-            <a:noFill/>
-          </a:ln>
-          <a:effectLst/>
-        </p:spPr>
-        <p:style>
-          <a:lnRef idx="1">
-            <a:schemeClr val="accent1"/>
-          </a:lnRef>
-          <a:fillRef idx="3">
-            <a:schemeClr val="accent1"/>
-          </a:fillRef>
-          <a:effectRef idx="2">
-            <a:schemeClr val="accent1"/>
-          </a:effectRef>
-          <a:fontRef idx="minor">
-            <a:schemeClr val="lt1"/>
-          </a:fontRef>
-        </p:style>
-        <p:txBody>
-          <a:bodyPr rtlCol="0" anchor="ctr" wrap="square" lIns="73152" rIns="73152" tIns="36576" bIns="36576"/>
-          <a:lstStyle/>
-          <a:p>
-            <a:pPr algn="ctr"/>
-            <a:r>
-              <a:rPr sz="1300" b="1">
+              <a:t>Watchlist — 10 real companies</a:t>
+            </a:r>
+          </a:p>
+        </p:txBody>
+      </p:sp>
+      <p:sp>
+        <p:nvSpPr>
+          <p:cNvPr id="13" name="TextBox 12"/>
+          <p:cNvSpPr txBox="1"/>
+          <p:nvPr/>
+        </p:nvSpPr>
+        <p:spPr>
+          <a:xfrm>
+            <a:off x="411480" y="4510922"/>
+            <a:ext cx="4069080" cy="1280160"/>
+          </a:xfrm>
+          <a:prstGeom prst="rect">
+            <a:avLst/>
+          </a:prstGeom>
+          <a:noFill/>
+        </p:spPr>
+        <p:txBody>
+          <a:bodyPr wrap="square" lIns="36576" rIns="36576" tIns="18288" bIns="18288" anchor="t">
+            <a:spAutoFit/>
+          </a:bodyPr>
+          <a:lstStyle/>
+          <a:p>
+            <a:pPr algn="l" marL="201168" indent="-182880">
+              <a:spcAft>
+                <a:spcPts val="400"/>
+              </a:spcAft>
+              <a:buClr>
+                <a:srgbClr val="9F1C33"/>
+              </a:buClr>
+              <a:buFont typeface="Arial"/>
+              <a:buChar char="•"/>
+            </a:pPr>
+            <a:r>
+              <a:rPr sz="1200" b="0" i="0">
+                <a:solidFill>
+                  <a:srgbClr val="262626"/>
+                </a:solidFill>
+                <a:latin typeface="Times New Roman"/>
+              </a:rPr>
+              <a:t>Latest call per company: six aspect scores and the brief's stance</a:t>
+            </a:r>
+          </a:p>
+          <a:p>
+            <a:pPr algn="l" marL="201168" indent="-182880">
+              <a:spcAft>
+                <a:spcPts val="400"/>
+              </a:spcAft>
+              <a:buClr>
+                <a:srgbClr val="9F1C33"/>
+              </a:buClr>
+              <a:buFont typeface="Arial"/>
+              <a:buChar char="•"/>
+            </a:pPr>
+            <a:r>
+              <a:rPr sz="1200" b="0" i="0">
+                <a:solidFill>
+                  <a:srgbClr val="262626"/>
+                </a:solidFill>
+                <a:latin typeface="Times New Roman"/>
+              </a:rPr>
+              <a:t>Top aspect moves across the watchlist</a:t>
+            </a:r>
+          </a:p>
+          <a:p>
+            <a:pPr algn="l" marL="201168" indent="-182880">
+              <a:spcAft>
+                <a:spcPts val="400"/>
+              </a:spcAft>
+              <a:buClr>
+                <a:srgbClr val="9F1C33"/>
+              </a:buClr>
+              <a:buFont typeface="Arial"/>
+              <a:buChar char="•"/>
+            </a:pPr>
+            <a:r>
+              <a:rPr sz="1200" b="0" i="0">
+                <a:solidFill>
+                  <a:srgbClr val="262626"/>
+                </a:solidFill>
+                <a:latin typeface="Times New Roman"/>
+              </a:rPr>
+              <a:t>⚠ marks aspects where the Q&amp;A ran well below the script</a:t>
+            </a:r>
+          </a:p>
+        </p:txBody>
+      </p:sp>
+      <p:sp>
+        <p:nvSpPr>
+          <p:cNvPr id="14" name="TextBox 13"/>
+          <p:cNvSpPr txBox="1"/>
+          <p:nvPr/>
+        </p:nvSpPr>
+        <p:spPr>
+          <a:xfrm>
+            <a:off x="4663440" y="4181738"/>
+            <a:ext cx="4069080" cy="310896"/>
+          </a:xfrm>
+          <a:prstGeom prst="rect">
+            <a:avLst/>
+          </a:prstGeom>
+          <a:noFill/>
+        </p:spPr>
+        <p:txBody>
+          <a:bodyPr wrap="square" lIns="36576" rIns="36576" tIns="18288" bIns="18288" anchor="t">
+            <a:spAutoFit/>
+          </a:bodyPr>
+          <a:lstStyle/>
+          <a:p>
+            <a:pPr algn="l">
+              <a:spcAft>
+                <a:spcPts val="400"/>
+              </a:spcAft>
+            </a:pPr>
+            <a:r>
+              <a:rPr sz="1300" b="1" i="0">
                 <a:solidFill>
                   <a:srgbClr val="9F1C33"/>
                 </a:solidFill>
                 <a:latin typeface="Times New Roman"/>
               </a:rPr>
-              <a:t>Watchlist &amp; top moves</a:t>
-            </a:r>
-          </a:p>
-          <a:p>
-            <a:pPr algn="ctr"/>
-            <a:r>
-              <a:rPr sz="1100" b="0">
-                <a:solidFill>
-                  <a:srgbClr val="595959"/>
+              <a:t>Company view — Boeing, 2015–2025</a:t>
+            </a:r>
+          </a:p>
+        </p:txBody>
+      </p:sp>
+      <p:sp>
+        <p:nvSpPr>
+          <p:cNvPr id="15" name="TextBox 14"/>
+          <p:cNvSpPr txBox="1"/>
+          <p:nvPr/>
+        </p:nvSpPr>
+        <p:spPr>
+          <a:xfrm>
+            <a:off x="4663440" y="4510922"/>
+            <a:ext cx="4069080" cy="1280160"/>
+          </a:xfrm>
+          <a:prstGeom prst="rect">
+            <a:avLst/>
+          </a:prstGeom>
+          <a:noFill/>
+        </p:spPr>
+        <p:txBody>
+          <a:bodyPr wrap="square" lIns="36576" rIns="36576" tIns="18288" bIns="18288" anchor="t">
+            <a:spAutoFit/>
+          </a:bodyPr>
+          <a:lstStyle/>
+          <a:p>
+            <a:pPr algn="l" marL="201168" indent="-182880">
+              <a:spcAft>
+                <a:spcPts val="400"/>
+              </a:spcAft>
+              <a:buClr>
+                <a:srgbClr val="9F1C33"/>
+              </a:buClr>
+              <a:buFont typeface="Arial"/>
+              <a:buChar char="•"/>
+            </a:pPr>
+            <a:r>
+              <a:rPr sz="1200" b="0" i="0">
+                <a:solidFill>
+                  <a:srgbClr val="262626"/>
                 </a:solidFill>
                 <a:latin typeface="Times New Roman"/>
               </a:rPr>
-              <a:t>latest call per company, largest aspect changes</a:t>
-            </a:r>
-          </a:p>
-        </p:txBody>
-      </p:sp>
-      <p:sp>
-        <p:nvSpPr>
-          <p:cNvPr id="15" name="Rounded Rectangle 14"/>
-          <p:cNvSpPr/>
-          <p:nvPr/>
-        </p:nvSpPr>
-        <p:spPr>
-          <a:xfrm>
-            <a:off x="3218688" y="4160520"/>
-            <a:ext cx="2697480" cy="1005840"/>
-          </a:xfrm>
-          <a:prstGeom prst="roundRect">
-            <a:avLst>
-              <a:gd name="adj" fmla="val 8000"/>
-            </a:avLst>
-          </a:prstGeom>
-          <a:solidFill>
-            <a:srgbClr val="F6E4E7"/>
-          </a:solidFill>
-          <a:ln>
-            <a:noFill/>
-          </a:ln>
-          <a:effectLst/>
-        </p:spPr>
-        <p:style>
-          <a:lnRef idx="1">
-            <a:schemeClr val="accent1"/>
-          </a:lnRef>
-          <a:fillRef idx="3">
-            <a:schemeClr val="accent1"/>
-          </a:fillRef>
-          <a:effectRef idx="2">
-            <a:schemeClr val="accent1"/>
-          </a:effectRef>
-          <a:fontRef idx="minor">
-            <a:schemeClr val="lt1"/>
-          </a:fontRef>
-        </p:style>
-        <p:txBody>
-          <a:bodyPr rtlCol="0" anchor="ctr" wrap="square" lIns="73152" rIns="73152" tIns="36576" bIns="36576"/>
-          <a:lstStyle/>
-          <a:p>
-            <a:pPr algn="ctr"/>
-            <a:r>
-              <a:rPr sz="1300" b="1">
-                <a:solidFill>
-                  <a:srgbClr val="9F1C33"/>
+              <a:t>One chart per aspect across ~40 quarterly calls</a:t>
+            </a:r>
+          </a:p>
+          <a:p>
+            <a:pPr algn="l" marL="201168" indent="-182880">
+              <a:spcAft>
+                <a:spcPts val="400"/>
+              </a:spcAft>
+              <a:buClr>
+                <a:srgbClr val="9F1C33"/>
+              </a:buClr>
+              <a:buFont typeface="Arial"/>
+              <a:buChar char="•"/>
+            </a:pPr>
+            <a:r>
+              <a:rPr sz="1200" b="0" i="0">
+                <a:solidFill>
+                  <a:srgbClr val="262626"/>
                 </a:solidFill>
                 <a:latin typeface="Times New Roman"/>
               </a:rPr>
-              <a:t>Drill-down</a:t>
-            </a:r>
-          </a:p>
-          <a:p>
-            <a:pPr algn="ctr"/>
-            <a:r>
-              <a:rPr sz="1100" b="0">
-                <a:solidFill>
-                  <a:srgbClr val="595959"/>
+              <a:t>Green / red dashed lines: prepared remarks vs Q&amp;A</a:t>
+            </a:r>
+          </a:p>
+          <a:p>
+            <a:pPr algn="l" marL="201168" indent="-182880">
+              <a:spcAft>
+                <a:spcPts val="400"/>
+              </a:spcAft>
+              <a:buClr>
+                <a:srgbClr val="9F1C33"/>
+              </a:buClr>
+              <a:buFont typeface="Arial"/>
+              <a:buChar char="•"/>
+            </a:pPr>
+            <a:r>
+              <a:rPr sz="1200" b="0" i="0">
+                <a:solidFill>
+                  <a:srgbClr val="262626"/>
                 </a:solidFill>
                 <a:latin typeface="Times New Roman"/>
               </a:rPr>
-              <a:t>chart point → sentences → source in context → model verdict</a:t>
-            </a:r>
-          </a:p>
-        </p:txBody>
-      </p:sp>
-      <p:sp>
-        <p:nvSpPr>
-          <p:cNvPr id="16" name="Rounded Rectangle 15"/>
-          <p:cNvSpPr/>
-          <p:nvPr/>
-        </p:nvSpPr>
-        <p:spPr>
-          <a:xfrm>
-            <a:off x="6025896" y="4160520"/>
-            <a:ext cx="2697480" cy="1005840"/>
-          </a:xfrm>
-          <a:prstGeom prst="roundRect">
-            <a:avLst>
-              <a:gd name="adj" fmla="val 8000"/>
-            </a:avLst>
-          </a:prstGeom>
-          <a:solidFill>
-            <a:srgbClr val="F6E4E7"/>
-          </a:solidFill>
-          <a:ln>
-            <a:noFill/>
-          </a:ln>
-          <a:effectLst/>
-        </p:spPr>
-        <p:style>
-          <a:lnRef idx="1">
-            <a:schemeClr val="accent1"/>
-          </a:lnRef>
-          <a:fillRef idx="3">
-            <a:schemeClr val="accent1"/>
-          </a:fillRef>
-          <a:effectRef idx="2">
-            <a:schemeClr val="accent1"/>
-          </a:effectRef>
-          <a:fontRef idx="minor">
-            <a:schemeClr val="lt1"/>
-          </a:fontRef>
-        </p:style>
-        <p:txBody>
-          <a:bodyPr rtlCol="0" anchor="ctr" wrap="square" lIns="73152" rIns="73152" tIns="36576" bIns="36576"/>
-          <a:lstStyle/>
-          <a:p>
-            <a:pPr algn="ctr"/>
-            <a:r>
-              <a:rPr sz="1300" b="1">
-                <a:solidFill>
-                  <a:srgbClr val="9F1C33"/>
-                </a:solidFill>
-                <a:latin typeface="Times New Roman"/>
-              </a:rPr>
-              <a:t>Monitoring</a:t>
-            </a:r>
-          </a:p>
-          <a:p>
-            <a:pPr algn="ctr"/>
-            <a:r>
-              <a:rPr sz="1100" b="0">
-                <a:solidFill>
-                  <a:srgbClr val="595959"/>
-                </a:solidFill>
-                <a:latin typeface="Times New Roman"/>
-              </a:rPr>
-              <a:t>quarterly drift (PSI), model registry, daily digest</a:t>
+              <a:t>Click any point to see the sentences behind it</a:t>
             </a:r>
           </a:p>
         </p:txBody>
@@ -10146,7 +10259,7 @@
             </a:pPr>
             <a:r>
               <a:rPr spc="-10" dirty="0"/>
-              <a:t>REAL-DATA PILOT &amp; SIGNAL STUDY</a:t>
+              <a:t>WEBSITE: DRILL-DOWN &amp; BRIEF</a:t>
             </a:r>
             <a:endParaRPr spc="-10" dirty="0"/>
           </a:p>
@@ -10187,6 +10300,1082 @@
                 <a:cs typeface="Calibri"/>
               </a:rPr>
               <a:t>9</a:t>
+            </a:r>
+          </a:p>
+        </p:txBody>
+      </p:sp>
+      <p:sp>
+        <p:nvSpPr>
+          <p:cNvPr id="9" name="object 9"/>
+          <p:cNvSpPr txBox="1">
+            <a:spLocks noGrp="1"/>
+          </p:cNvSpPr>
+          <p:nvPr>
+            <p:ph type="ftr" sz="quarter" idx="5"/>
+          </p:nvPr>
+        </p:nvSpPr>
+        <p:spPr>
+          <a:xfrm>
+            <a:off x="1107744" y="6452870"/>
+            <a:ext cx="3411880" cy="182038"/>
+          </a:xfrm>
+          <a:prstGeom prst="rect">
+            <a:avLst/>
+          </a:prstGeom>
+        </p:spPr>
+        <p:txBody>
+          <a:bodyPr vert="horz" wrap="square" lIns="0" tIns="0" rIns="0" bIns="0" rtlCol="0">
+            <a:spAutoFit/>
+          </a:bodyPr>
+          <a:lstStyle/>
+          <a:p>
+            <a:pPr marL="12700">
+              <a:lnSpc>
+                <a:spcPts val="1435"/>
+              </a:lnSpc>
+            </a:pPr>
+            <a:r>
+              <a:rPr sz="1400" dirty="0"/>
+              <a:t>Sentari — Sentiment Analysis (231CAUEC51)</a:t>
+            </a:r>
+          </a:p>
+        </p:txBody>
+      </p:sp>
+      <p:pic>
+        <p:nvPicPr>
+          <p:cNvPr id="10" name="Picture 9" descr="pilot_ba_source_crop.png"/>
+          <p:cNvPicPr>
+            <a:picLocks noChangeAspect="1"/>
+          </p:cNvPicPr>
+          <p:nvPr/>
+        </p:nvPicPr>
+        <p:blipFill>
+          <a:blip r:embed="rId3"/>
+          <a:stretch>
+            <a:fillRect/>
+          </a:stretch>
+        </p:blipFill>
+        <p:spPr>
+          <a:xfrm>
+            <a:off x="411480" y="1298448"/>
+            <a:ext cx="4069080" cy="2660979"/>
+          </a:xfrm>
+          <a:prstGeom prst="rect">
+            <a:avLst/>
+          </a:prstGeom>
+          <a:ln w="9525">
+            <a:solidFill>
+              <a:srgbClr val="BFBFBF"/>
+            </a:solidFill>
+          </a:ln>
+        </p:spPr>
+      </p:pic>
+      <p:pic>
+        <p:nvPicPr>
+          <p:cNvPr id="11" name="Picture 10" descr="pilot_ba_brief_crop.png"/>
+          <p:cNvPicPr>
+            <a:picLocks noChangeAspect="1"/>
+          </p:cNvPicPr>
+          <p:nvPr/>
+        </p:nvPicPr>
+        <p:blipFill>
+          <a:blip r:embed="rId4"/>
+          <a:stretch>
+            <a:fillRect/>
+          </a:stretch>
+        </p:blipFill>
+        <p:spPr>
+          <a:xfrm>
+            <a:off x="4663440" y="1298448"/>
+            <a:ext cx="4069080" cy="2810138"/>
+          </a:xfrm>
+          <a:prstGeom prst="rect">
+            <a:avLst/>
+          </a:prstGeom>
+          <a:ln w="9525">
+            <a:solidFill>
+              <a:srgbClr val="BFBFBF"/>
+            </a:solidFill>
+          </a:ln>
+        </p:spPr>
+      </p:pic>
+      <p:sp>
+        <p:nvSpPr>
+          <p:cNvPr id="12" name="TextBox 11"/>
+          <p:cNvSpPr txBox="1"/>
+          <p:nvPr/>
+        </p:nvSpPr>
+        <p:spPr>
+          <a:xfrm>
+            <a:off x="411480" y="4181738"/>
+            <a:ext cx="4069080" cy="310896"/>
+          </a:xfrm>
+          <a:prstGeom prst="rect">
+            <a:avLst/>
+          </a:prstGeom>
+          <a:noFill/>
+        </p:spPr>
+        <p:txBody>
+          <a:bodyPr wrap="square" lIns="36576" rIns="36576" tIns="18288" bIns="18288" anchor="t">
+            <a:spAutoFit/>
+          </a:bodyPr>
+          <a:lstStyle/>
+          <a:p>
+            <a:pPr algn="l">
+              <a:spcAft>
+                <a:spcPts val="400"/>
+              </a:spcAft>
+            </a:pPr>
+            <a:r>
+              <a:rPr sz="1300" b="1" i="0">
+                <a:solidFill>
+                  <a:srgbClr val="9F1C33"/>
+                </a:solidFill>
+                <a:latin typeface="Times New Roman"/>
+              </a:rPr>
+              <a:t>From chart point to source sentence</a:t>
+            </a:r>
+          </a:p>
+        </p:txBody>
+      </p:sp>
+      <p:sp>
+        <p:nvSpPr>
+          <p:cNvPr id="13" name="TextBox 12"/>
+          <p:cNvSpPr txBox="1"/>
+          <p:nvPr/>
+        </p:nvSpPr>
+        <p:spPr>
+          <a:xfrm>
+            <a:off x="411480" y="4510922"/>
+            <a:ext cx="4069080" cy="1280160"/>
+          </a:xfrm>
+          <a:prstGeom prst="rect">
+            <a:avLst/>
+          </a:prstGeom>
+          <a:noFill/>
+        </p:spPr>
+        <p:txBody>
+          <a:bodyPr wrap="square" lIns="36576" rIns="36576" tIns="18288" bIns="18288" anchor="t">
+            <a:spAutoFit/>
+          </a:bodyPr>
+          <a:lstStyle/>
+          <a:p>
+            <a:pPr algn="l" marL="201168" indent="-182880">
+              <a:spcAft>
+                <a:spcPts val="400"/>
+              </a:spcAft>
+              <a:buClr>
+                <a:srgbClr val="9F1C33"/>
+              </a:buClr>
+              <a:buFont typeface="Arial"/>
+              <a:buChar char="•"/>
+            </a:pPr>
+            <a:r>
+              <a:rPr sz="1200" b="0" i="0">
+                <a:solidFill>
+                  <a:srgbClr val="262626"/>
+                </a:solidFill>
+                <a:latin typeface="Times New Roman"/>
+              </a:rPr>
+              <a:t>Scored sentences from both models for that call</a:t>
+            </a:r>
+          </a:p>
+          <a:p>
+            <a:pPr algn="l" marL="201168" indent="-182880">
+              <a:spcAft>
+                <a:spcPts val="400"/>
+              </a:spcAft>
+              <a:buClr>
+                <a:srgbClr val="9F1C33"/>
+              </a:buClr>
+              <a:buFont typeface="Arial"/>
+              <a:buChar char="•"/>
+            </a:pPr>
+            <a:r>
+              <a:rPr sz="1200" b="0" i="0">
+                <a:solidFill>
+                  <a:srgbClr val="262626"/>
+                </a:solidFill>
+                <a:latin typeface="Times New Roman"/>
+              </a:rPr>
+              <a:t>The sentence in context, with its speaker</a:t>
+            </a:r>
+          </a:p>
+          <a:p>
+            <a:pPr algn="l" marL="201168" indent="-182880">
+              <a:spcAft>
+                <a:spcPts val="400"/>
+              </a:spcAft>
+              <a:buClr>
+                <a:srgbClr val="9F1C33"/>
+              </a:buClr>
+              <a:buFont typeface="Arial"/>
+              <a:buChar char="•"/>
+            </a:pPr>
+            <a:r>
+              <a:rPr sz="1200" b="0" i="0">
+                <a:solidFill>
+                  <a:srgbClr val="262626"/>
+                </a:solidFill>
+                <a:latin typeface="Times New Roman"/>
+              </a:rPr>
+              <a:t>Every stored model verdict for the sentence</a:t>
+            </a:r>
+          </a:p>
+        </p:txBody>
+      </p:sp>
+      <p:sp>
+        <p:nvSpPr>
+          <p:cNvPr id="14" name="TextBox 13"/>
+          <p:cNvSpPr txBox="1"/>
+          <p:nvPr/>
+        </p:nvSpPr>
+        <p:spPr>
+          <a:xfrm>
+            <a:off x="4663440" y="4181738"/>
+            <a:ext cx="4069080" cy="310896"/>
+          </a:xfrm>
+          <a:prstGeom prst="rect">
+            <a:avLst/>
+          </a:prstGeom>
+          <a:noFill/>
+        </p:spPr>
+        <p:txBody>
+          <a:bodyPr wrap="square" lIns="36576" rIns="36576" tIns="18288" bIns="18288" anchor="t">
+            <a:spAutoFit/>
+          </a:bodyPr>
+          <a:lstStyle/>
+          <a:p>
+            <a:pPr algn="l">
+              <a:spcAft>
+                <a:spcPts val="400"/>
+              </a:spcAft>
+            </a:pPr>
+            <a:r>
+              <a:rPr sz="1300" b="1" i="0">
+                <a:solidFill>
+                  <a:srgbClr val="9F1C33"/>
+                </a:solidFill>
+                <a:latin typeface="Times New Roman"/>
+              </a:rPr>
+              <a:t>Brief for Boeing (Oct 2024 – Apr 2025)</a:t>
+            </a:r>
+          </a:p>
+        </p:txBody>
+      </p:sp>
+      <p:sp>
+        <p:nvSpPr>
+          <p:cNvPr id="15" name="TextBox 14"/>
+          <p:cNvSpPr txBox="1"/>
+          <p:nvPr/>
+        </p:nvSpPr>
+        <p:spPr>
+          <a:xfrm>
+            <a:off x="4663440" y="4510922"/>
+            <a:ext cx="4069080" cy="1280160"/>
+          </a:xfrm>
+          <a:prstGeom prst="rect">
+            <a:avLst/>
+          </a:prstGeom>
+          <a:noFill/>
+        </p:spPr>
+        <p:txBody>
+          <a:bodyPr wrap="square" lIns="36576" rIns="36576" tIns="18288" bIns="18288" anchor="t">
+            <a:spAutoFit/>
+          </a:bodyPr>
+          <a:lstStyle/>
+          <a:p>
+            <a:pPr algn="l" marL="201168" indent="-182880">
+              <a:spcAft>
+                <a:spcPts val="400"/>
+              </a:spcAft>
+              <a:buClr>
+                <a:srgbClr val="9F1C33"/>
+              </a:buClr>
+              <a:buFont typeface="Arial"/>
+              <a:buChar char="•"/>
+            </a:pPr>
+            <a:r>
+              <a:rPr sz="1200" b="0" i="0">
+                <a:solidFill>
+                  <a:srgbClr val="262626"/>
+                </a:solidFill>
+                <a:latin typeface="Times New Roman"/>
+              </a:rPr>
+              <a:t>Stance and a transparent confidence breakdown</a:t>
+            </a:r>
+          </a:p>
+          <a:p>
+            <a:pPr algn="l" marL="201168" indent="-182880">
+              <a:spcAft>
+                <a:spcPts val="400"/>
+              </a:spcAft>
+              <a:buClr>
+                <a:srgbClr val="9F1C33"/>
+              </a:buClr>
+              <a:buFont typeface="Arial"/>
+              <a:buChar char="•"/>
+            </a:pPr>
+            <a:r>
+              <a:rPr sz="1200" b="0" i="0">
+                <a:solidFill>
+                  <a:srgbClr val="262626"/>
+                </a:solidFill>
+                <a:latin typeface="Times New Roman"/>
+              </a:rPr>
+              <a:t>Bull and bear claims, each citing its source (src chips)</a:t>
+            </a:r>
+          </a:p>
+          <a:p>
+            <a:pPr algn="l" marL="201168" indent="-182880">
+              <a:spcAft>
+                <a:spcPts val="400"/>
+              </a:spcAft>
+              <a:buClr>
+                <a:srgbClr val="9F1C33"/>
+              </a:buClr>
+              <a:buFont typeface="Arial"/>
+              <a:buChar char="•"/>
+            </a:pPr>
+            <a:r>
+              <a:rPr sz="1200" b="0" i="0">
+                <a:solidFill>
+                  <a:srgbClr val="262626"/>
+                </a:solidFill>
+                <a:latin typeface="Times New Roman"/>
+              </a:rPr>
+              <a:t>Cash burn, 777X costs and tariffs surface from real calls</a:t>
+            </a:r>
+          </a:p>
+        </p:txBody>
+      </p:sp>
+    </p:spTree>
+  </p:cSld>
+  <p:clrMapOvr>
+    <a:masterClrMapping/>
+  </p:clrMapOvr>
+</p:sld>
+</file>
+
+<file path=ppt/slides/slide23.xml><?xml version="1.0" encoding="utf-8"?>
+<p:sld xmlns:a="http://schemas.openxmlformats.org/drawingml/2006/main" xmlns:r="http://schemas.openxmlformats.org/officeDocument/2006/relationships" xmlns:p="http://schemas.openxmlformats.org/presentationml/2006/main" showMasterSp="0">
+  <p:cSld>
+    <p:spTree>
+      <p:nvGrpSpPr>
+        <p:cNvPr id="1" name=""/>
+        <p:cNvGrpSpPr/>
+        <p:nvPr/>
+      </p:nvGrpSpPr>
+      <p:grpSpPr>
+        <a:xfrm>
+          <a:off x="0" y="0"/>
+          <a:ext cx="0" cy="0"/>
+          <a:chOff x="0" y="0"/>
+          <a:chExt cx="0" cy="0"/>
+        </a:xfrm>
+      </p:grpSpPr>
+      <p:sp>
+        <p:nvSpPr>
+          <p:cNvPr id="2" name="object 2"/>
+          <p:cNvSpPr/>
+          <p:nvPr/>
+        </p:nvSpPr>
+        <p:spPr>
+          <a:xfrm>
+            <a:off x="971550" y="6381750"/>
+            <a:ext cx="0" cy="360680"/>
+          </a:xfrm>
+          <a:custGeom>
+            <a:avLst/>
+            <a:gdLst/>
+            <a:ahLst/>
+            <a:cxnLst/>
+            <a:rect l="l" t="t" r="r" b="b"/>
+            <a:pathLst>
+              <a:path h="360679">
+                <a:moveTo>
+                  <a:pt x="0" y="0"/>
+                </a:moveTo>
+                <a:lnTo>
+                  <a:pt x="0" y="360362"/>
+                </a:lnTo>
+              </a:path>
+            </a:pathLst>
+          </a:custGeom>
+          <a:ln w="9525">
+            <a:solidFill>
+              <a:srgbClr val="0D0D0D"/>
+            </a:solidFill>
+          </a:ln>
+        </p:spPr>
+        <p:txBody>
+          <a:bodyPr wrap="square" lIns="0" tIns="0" rIns="0" bIns="0" rtlCol="0"/>
+          <a:lstStyle/>
+          <a:p>
+            <a:endParaRPr/>
+          </a:p>
+        </p:txBody>
+      </p:sp>
+      <p:sp>
+        <p:nvSpPr>
+          <p:cNvPr id="3" name="object 3"/>
+          <p:cNvSpPr/>
+          <p:nvPr/>
+        </p:nvSpPr>
+        <p:spPr>
+          <a:xfrm>
+            <a:off x="395287" y="1125600"/>
+            <a:ext cx="8354059" cy="0"/>
+          </a:xfrm>
+          <a:custGeom>
+            <a:avLst/>
+            <a:gdLst/>
+            <a:ahLst/>
+            <a:cxnLst/>
+            <a:rect l="l" t="t" r="r" b="b"/>
+            <a:pathLst>
+              <a:path w="8354059">
+                <a:moveTo>
+                  <a:pt x="0" y="0"/>
+                </a:moveTo>
+                <a:lnTo>
+                  <a:pt x="8353488" y="0"/>
+                </a:lnTo>
+              </a:path>
+            </a:pathLst>
+          </a:custGeom>
+          <a:ln w="9525">
+            <a:solidFill>
+              <a:srgbClr val="404040"/>
+            </a:solidFill>
+          </a:ln>
+        </p:spPr>
+        <p:txBody>
+          <a:bodyPr wrap="square" lIns="0" tIns="0" rIns="0" bIns="0" rtlCol="0"/>
+          <a:lstStyle/>
+          <a:p>
+            <a:endParaRPr/>
+          </a:p>
+        </p:txBody>
+      </p:sp>
+      <p:pic>
+        <p:nvPicPr>
+          <p:cNvPr id="4" name="object 4"/>
+          <p:cNvPicPr/>
+          <p:nvPr/>
+        </p:nvPicPr>
+        <p:blipFill>
+          <a:blip r:embed="rId2" cstate="print"/>
+          <a:stretch>
+            <a:fillRect/>
+          </a:stretch>
+        </p:blipFill>
+        <p:spPr>
+          <a:xfrm>
+            <a:off x="6340475" y="5595936"/>
+            <a:ext cx="2803525" cy="1262060"/>
+          </a:xfrm>
+          <a:prstGeom prst="rect">
+            <a:avLst/>
+          </a:prstGeom>
+        </p:spPr>
+      </p:pic>
+      <p:sp>
+        <p:nvSpPr>
+          <p:cNvPr id="6" name="object 6"/>
+          <p:cNvSpPr txBox="1">
+            <a:spLocks noGrp="1"/>
+          </p:cNvSpPr>
+          <p:nvPr>
+            <p:ph type="title"/>
+          </p:nvPr>
+        </p:nvSpPr>
+        <p:spPr>
+          <a:xfrm>
+            <a:off x="535940" y="450849"/>
+            <a:ext cx="5966459" cy="487390"/>
+          </a:xfrm>
+          <a:prstGeom prst="rect">
+            <a:avLst/>
+          </a:prstGeom>
+        </p:spPr>
+        <p:txBody>
+          <a:bodyPr vert="horz" wrap="square" lIns="0" tIns="55956" rIns="0" bIns="0" rtlCol="0">
+            <a:spAutoFit/>
+          </a:bodyPr>
+          <a:lstStyle/>
+          <a:p>
+            <a:pPr marL="12700">
+              <a:lnSpc>
+                <a:spcPct val="100000"/>
+              </a:lnSpc>
+              <a:spcBef>
+                <a:spcPts val="95"/>
+              </a:spcBef>
+            </a:pPr>
+            <a:r>
+              <a:rPr spc="-10" dirty="0"/>
+              <a:t>WEBSITE: AUDIT, MONITORING &amp; API</a:t>
+            </a:r>
+            <a:endParaRPr spc="-10" dirty="0"/>
+          </a:p>
+        </p:txBody>
+      </p:sp>
+      <p:sp>
+        <p:nvSpPr>
+          <p:cNvPr id="8" name="object 8"/>
+          <p:cNvSpPr txBox="1"/>
+          <p:nvPr/>
+        </p:nvSpPr>
+        <p:spPr>
+          <a:xfrm>
+            <a:off x="566928" y="6452870"/>
+            <a:ext cx="329184" cy="204470"/>
+          </a:xfrm>
+          <a:prstGeom prst="rect">
+            <a:avLst/>
+          </a:prstGeom>
+        </p:spPr>
+        <p:txBody>
+          <a:bodyPr vert="horz" wrap="none" lIns="0" tIns="0" rIns="0" bIns="0" rtlCol="0">
+            <a:spAutoFit/>
+          </a:bodyPr>
+          <a:lstStyle/>
+          <a:p>
+            <a:pPr marL="12700" algn="r">
+              <a:lnSpc>
+                <a:spcPts val="1435"/>
+              </a:lnSpc>
+            </a:pPr>
+            <a:r>
+              <a:rPr sz="1400" spc="-50" dirty="0">
+                <a:solidFill>
+                  <a:srgbClr val="404040"/>
+                </a:solidFill>
+                <a:latin typeface="Calibri"/>
+                <a:cs typeface="Calibri"/>
+              </a:rPr>
+              <a:t>10</a:t>
+            </a:r>
+          </a:p>
+        </p:txBody>
+      </p:sp>
+      <p:sp>
+        <p:nvSpPr>
+          <p:cNvPr id="9" name="object 9"/>
+          <p:cNvSpPr txBox="1">
+            <a:spLocks noGrp="1"/>
+          </p:cNvSpPr>
+          <p:nvPr>
+            <p:ph type="ftr" sz="quarter" idx="5"/>
+          </p:nvPr>
+        </p:nvSpPr>
+        <p:spPr>
+          <a:xfrm>
+            <a:off x="1107744" y="6452870"/>
+            <a:ext cx="3411880" cy="182038"/>
+          </a:xfrm>
+          <a:prstGeom prst="rect">
+            <a:avLst/>
+          </a:prstGeom>
+        </p:spPr>
+        <p:txBody>
+          <a:bodyPr vert="horz" wrap="square" lIns="0" tIns="0" rIns="0" bIns="0" rtlCol="0">
+            <a:spAutoFit/>
+          </a:bodyPr>
+          <a:lstStyle/>
+          <a:p>
+            <a:pPr marL="12700">
+              <a:lnSpc>
+                <a:spcPts val="1435"/>
+              </a:lnSpc>
+            </a:pPr>
+            <a:r>
+              <a:rPr sz="1400" dirty="0"/>
+              <a:t>Sentari — Sentiment Analysis (231CAUEC51)</a:t>
+            </a:r>
+          </a:p>
+        </p:txBody>
+      </p:sp>
+      <p:pic>
+        <p:nvPicPr>
+          <p:cNvPr id="10" name="Picture 9" descr="pilot_ba_audit_crop.png"/>
+          <p:cNvPicPr>
+            <a:picLocks noChangeAspect="1"/>
+          </p:cNvPicPr>
+          <p:nvPr/>
+        </p:nvPicPr>
+        <p:blipFill>
+          <a:blip r:embed="rId3"/>
+          <a:stretch>
+            <a:fillRect/>
+          </a:stretch>
+        </p:blipFill>
+        <p:spPr>
+          <a:xfrm>
+            <a:off x="987495" y="1298448"/>
+            <a:ext cx="2917050" cy="1719072"/>
+          </a:xfrm>
+          <a:prstGeom prst="rect">
+            <a:avLst/>
+          </a:prstGeom>
+          <a:ln w="9525">
+            <a:solidFill>
+              <a:srgbClr val="BFBFBF"/>
+            </a:solidFill>
+          </a:ln>
+        </p:spPr>
+      </p:pic>
+      <p:sp>
+        <p:nvSpPr>
+          <p:cNvPr id="11" name="TextBox 10"/>
+          <p:cNvSpPr txBox="1"/>
+          <p:nvPr/>
+        </p:nvSpPr>
+        <p:spPr>
+          <a:xfrm>
+            <a:off x="411480" y="3054096"/>
+            <a:ext cx="4069080" cy="274320"/>
+          </a:xfrm>
+          <a:prstGeom prst="rect">
+            <a:avLst/>
+          </a:prstGeom>
+          <a:noFill/>
+        </p:spPr>
+        <p:txBody>
+          <a:bodyPr wrap="square" lIns="36576" rIns="36576" tIns="18288" bIns="18288" anchor="t">
+            <a:spAutoFit/>
+          </a:bodyPr>
+          <a:lstStyle/>
+          <a:p>
+            <a:pPr algn="ctr">
+              <a:spcAft>
+                <a:spcPts val="400"/>
+              </a:spcAft>
+            </a:pPr>
+            <a:r>
+              <a:rPr sz="1100" b="0" i="0">
+                <a:solidFill>
+                  <a:srgbClr val="595959"/>
+                </a:solidFill>
+                <a:latin typeface="Times New Roman"/>
+              </a:rPr>
+              <a:t>Agent audit trail: Skeptic checks + NLI probabilities</a:t>
+            </a:r>
+          </a:p>
+        </p:txBody>
+      </p:sp>
+      <p:pic>
+        <p:nvPicPr>
+          <p:cNvPr id="12" name="Picture 11" descr="pilot_drift_crop.png"/>
+          <p:cNvPicPr>
+            <a:picLocks noChangeAspect="1"/>
+          </p:cNvPicPr>
+          <p:nvPr/>
+        </p:nvPicPr>
+        <p:blipFill>
+          <a:blip r:embed="rId4"/>
+          <a:stretch>
+            <a:fillRect/>
+          </a:stretch>
+        </p:blipFill>
+        <p:spPr>
+          <a:xfrm>
+            <a:off x="5115851" y="1298448"/>
+            <a:ext cx="3164258" cy="1719072"/>
+          </a:xfrm>
+          <a:prstGeom prst="rect">
+            <a:avLst/>
+          </a:prstGeom>
+          <a:ln w="9525">
+            <a:solidFill>
+              <a:srgbClr val="BFBFBF"/>
+            </a:solidFill>
+          </a:ln>
+        </p:spPr>
+      </p:pic>
+      <p:sp>
+        <p:nvSpPr>
+          <p:cNvPr id="13" name="TextBox 12"/>
+          <p:cNvSpPr txBox="1"/>
+          <p:nvPr/>
+        </p:nvSpPr>
+        <p:spPr>
+          <a:xfrm>
+            <a:off x="4663440" y="3054096"/>
+            <a:ext cx="4069080" cy="274320"/>
+          </a:xfrm>
+          <a:prstGeom prst="rect">
+            <a:avLst/>
+          </a:prstGeom>
+          <a:noFill/>
+        </p:spPr>
+        <p:txBody>
+          <a:bodyPr wrap="square" lIns="36576" rIns="36576" tIns="18288" bIns="18288" anchor="t">
+            <a:spAutoFit/>
+          </a:bodyPr>
+          <a:lstStyle/>
+          <a:p>
+            <a:pPr algn="ctr">
+              <a:spcAft>
+                <a:spcPts val="400"/>
+              </a:spcAft>
+            </a:pPr>
+            <a:r>
+              <a:rPr sz="1100" b="0" i="0">
+                <a:solidFill>
+                  <a:srgbClr val="595959"/>
+                </a:solidFill>
+                <a:latin typeface="Times New Roman"/>
+              </a:rPr>
+              <a:t>Drift monitor: quarterly aspect-mix shift (PSI) per company</a:t>
+            </a:r>
+          </a:p>
+        </p:txBody>
+      </p:sp>
+      <p:pic>
+        <p:nvPicPr>
+          <p:cNvPr id="14" name="Picture 13" descr="pilot_models_crop.png"/>
+          <p:cNvPicPr>
+            <a:picLocks noChangeAspect="1"/>
+          </p:cNvPicPr>
+          <p:nvPr/>
+        </p:nvPicPr>
+        <p:blipFill>
+          <a:blip r:embed="rId5"/>
+          <a:stretch>
+            <a:fillRect/>
+          </a:stretch>
+        </p:blipFill>
+        <p:spPr>
+          <a:xfrm>
+            <a:off x="863891" y="3419856"/>
+            <a:ext cx="3164258" cy="1719072"/>
+          </a:xfrm>
+          <a:prstGeom prst="rect">
+            <a:avLst/>
+          </a:prstGeom>
+          <a:ln w="9525">
+            <a:solidFill>
+              <a:srgbClr val="BFBFBF"/>
+            </a:solidFill>
+          </a:ln>
+        </p:spPr>
+      </p:pic>
+      <p:sp>
+        <p:nvSpPr>
+          <p:cNvPr id="15" name="TextBox 14"/>
+          <p:cNvSpPr txBox="1"/>
+          <p:nvPr/>
+        </p:nvSpPr>
+        <p:spPr>
+          <a:xfrm>
+            <a:off x="411480" y="5175504"/>
+            <a:ext cx="4069080" cy="274320"/>
+          </a:xfrm>
+          <a:prstGeom prst="rect">
+            <a:avLst/>
+          </a:prstGeom>
+          <a:noFill/>
+        </p:spPr>
+        <p:txBody>
+          <a:bodyPr wrap="square" lIns="36576" rIns="36576" tIns="18288" bIns="18288" anchor="t">
+            <a:spAutoFit/>
+          </a:bodyPr>
+          <a:lstStyle/>
+          <a:p>
+            <a:pPr algn="ctr">
+              <a:spcAft>
+                <a:spcPts val="400"/>
+              </a:spcAft>
+            </a:pPr>
+            <a:r>
+              <a:rPr sz="1100" b="0" i="0">
+                <a:solidFill>
+                  <a:srgbClr val="595959"/>
+                </a:solidFill>
+                <a:latin typeface="Times New Roman"/>
+              </a:rPr>
+              <a:t>Model registry: every model, its test scores, which one serves</a:t>
+            </a:r>
+          </a:p>
+        </p:txBody>
+      </p:sp>
+      <p:pic>
+        <p:nvPicPr>
+          <p:cNvPr id="16" name="Picture 15" descr="pilot_api_docs_crop.png"/>
+          <p:cNvPicPr>
+            <a:picLocks noChangeAspect="1"/>
+          </p:cNvPicPr>
+          <p:nvPr/>
+        </p:nvPicPr>
+        <p:blipFill>
+          <a:blip r:embed="rId6"/>
+          <a:stretch>
+            <a:fillRect/>
+          </a:stretch>
+        </p:blipFill>
+        <p:spPr>
+          <a:xfrm>
+            <a:off x="4871466" y="3419856"/>
+            <a:ext cx="3653028" cy="1719072"/>
+          </a:xfrm>
+          <a:prstGeom prst="rect">
+            <a:avLst/>
+          </a:prstGeom>
+          <a:ln w="9525">
+            <a:solidFill>
+              <a:srgbClr val="BFBFBF"/>
+            </a:solidFill>
+          </a:ln>
+        </p:spPr>
+      </p:pic>
+      <p:sp>
+        <p:nvSpPr>
+          <p:cNvPr id="17" name="TextBox 16"/>
+          <p:cNvSpPr txBox="1"/>
+          <p:nvPr/>
+        </p:nvSpPr>
+        <p:spPr>
+          <a:xfrm>
+            <a:off x="4663440" y="5175504"/>
+            <a:ext cx="4069080" cy="274320"/>
+          </a:xfrm>
+          <a:prstGeom prst="rect">
+            <a:avLst/>
+          </a:prstGeom>
+          <a:noFill/>
+        </p:spPr>
+        <p:txBody>
+          <a:bodyPr wrap="square" lIns="36576" rIns="36576" tIns="18288" bIns="18288" anchor="t">
+            <a:spAutoFit/>
+          </a:bodyPr>
+          <a:lstStyle/>
+          <a:p>
+            <a:pPr algn="ctr">
+              <a:spcAft>
+                <a:spcPts val="400"/>
+              </a:spcAft>
+            </a:pPr>
+            <a:r>
+              <a:rPr sz="1100" b="0" i="0">
+                <a:solidFill>
+                  <a:srgbClr val="595959"/>
+                </a:solidFill>
+                <a:latin typeface="Times New Roman"/>
+              </a:rPr>
+              <a:t>FastAPI endpoints (interactive docs at /docs)</a:t>
+            </a:r>
+          </a:p>
+        </p:txBody>
+      </p:sp>
+    </p:spTree>
+  </p:cSld>
+  <p:clrMapOvr>
+    <a:masterClrMapping/>
+  </p:clrMapOvr>
+</p:sld>
+</file>
+
+<file path=ppt/slides/slide24.xml><?xml version="1.0" encoding="utf-8"?>
+<p:sld xmlns:a="http://schemas.openxmlformats.org/drawingml/2006/main" xmlns:r="http://schemas.openxmlformats.org/officeDocument/2006/relationships" xmlns:p="http://schemas.openxmlformats.org/presentationml/2006/main" showMasterSp="0">
+  <p:cSld>
+    <p:spTree>
+      <p:nvGrpSpPr>
+        <p:cNvPr id="1" name=""/>
+        <p:cNvGrpSpPr/>
+        <p:nvPr/>
+      </p:nvGrpSpPr>
+      <p:grpSpPr>
+        <a:xfrm>
+          <a:off x="0" y="0"/>
+          <a:ext cx="0" cy="0"/>
+          <a:chOff x="0" y="0"/>
+          <a:chExt cx="0" cy="0"/>
+        </a:xfrm>
+      </p:grpSpPr>
+      <p:sp>
+        <p:nvSpPr>
+          <p:cNvPr id="2" name="object 2"/>
+          <p:cNvSpPr/>
+          <p:nvPr/>
+        </p:nvSpPr>
+        <p:spPr>
+          <a:xfrm>
+            <a:off x="971550" y="6381750"/>
+            <a:ext cx="0" cy="360680"/>
+          </a:xfrm>
+          <a:custGeom>
+            <a:avLst/>
+            <a:gdLst/>
+            <a:ahLst/>
+            <a:cxnLst/>
+            <a:rect l="l" t="t" r="r" b="b"/>
+            <a:pathLst>
+              <a:path h="360679">
+                <a:moveTo>
+                  <a:pt x="0" y="0"/>
+                </a:moveTo>
+                <a:lnTo>
+                  <a:pt x="0" y="360362"/>
+                </a:lnTo>
+              </a:path>
+            </a:pathLst>
+          </a:custGeom>
+          <a:ln w="9525">
+            <a:solidFill>
+              <a:srgbClr val="0D0D0D"/>
+            </a:solidFill>
+          </a:ln>
+        </p:spPr>
+        <p:txBody>
+          <a:bodyPr wrap="square" lIns="0" tIns="0" rIns="0" bIns="0" rtlCol="0"/>
+          <a:lstStyle/>
+          <a:p>
+            <a:endParaRPr/>
+          </a:p>
+        </p:txBody>
+      </p:sp>
+      <p:sp>
+        <p:nvSpPr>
+          <p:cNvPr id="3" name="object 3"/>
+          <p:cNvSpPr/>
+          <p:nvPr/>
+        </p:nvSpPr>
+        <p:spPr>
+          <a:xfrm>
+            <a:off x="395287" y="1125600"/>
+            <a:ext cx="8354059" cy="0"/>
+          </a:xfrm>
+          <a:custGeom>
+            <a:avLst/>
+            <a:gdLst/>
+            <a:ahLst/>
+            <a:cxnLst/>
+            <a:rect l="l" t="t" r="r" b="b"/>
+            <a:pathLst>
+              <a:path w="8354059">
+                <a:moveTo>
+                  <a:pt x="0" y="0"/>
+                </a:moveTo>
+                <a:lnTo>
+                  <a:pt x="8353488" y="0"/>
+                </a:lnTo>
+              </a:path>
+            </a:pathLst>
+          </a:custGeom>
+          <a:ln w="9525">
+            <a:solidFill>
+              <a:srgbClr val="404040"/>
+            </a:solidFill>
+          </a:ln>
+        </p:spPr>
+        <p:txBody>
+          <a:bodyPr wrap="square" lIns="0" tIns="0" rIns="0" bIns="0" rtlCol="0"/>
+          <a:lstStyle/>
+          <a:p>
+            <a:endParaRPr/>
+          </a:p>
+        </p:txBody>
+      </p:sp>
+      <p:pic>
+        <p:nvPicPr>
+          <p:cNvPr id="4" name="object 4"/>
+          <p:cNvPicPr/>
+          <p:nvPr/>
+        </p:nvPicPr>
+        <p:blipFill>
+          <a:blip r:embed="rId2" cstate="print"/>
+          <a:stretch>
+            <a:fillRect/>
+          </a:stretch>
+        </p:blipFill>
+        <p:spPr>
+          <a:xfrm>
+            <a:off x="6340475" y="5595936"/>
+            <a:ext cx="2803525" cy="1262060"/>
+          </a:xfrm>
+          <a:prstGeom prst="rect">
+            <a:avLst/>
+          </a:prstGeom>
+        </p:spPr>
+      </p:pic>
+      <p:sp>
+        <p:nvSpPr>
+          <p:cNvPr id="6" name="object 6"/>
+          <p:cNvSpPr txBox="1">
+            <a:spLocks noGrp="1"/>
+          </p:cNvSpPr>
+          <p:nvPr>
+            <p:ph type="title"/>
+          </p:nvPr>
+        </p:nvSpPr>
+        <p:spPr>
+          <a:xfrm>
+            <a:off x="535940" y="450849"/>
+            <a:ext cx="5966459" cy="487390"/>
+          </a:xfrm>
+          <a:prstGeom prst="rect">
+            <a:avLst/>
+          </a:prstGeom>
+        </p:spPr>
+        <p:txBody>
+          <a:bodyPr vert="horz" wrap="square" lIns="0" tIns="55956" rIns="0" bIns="0" rtlCol="0">
+            <a:spAutoFit/>
+          </a:bodyPr>
+          <a:lstStyle/>
+          <a:p>
+            <a:pPr marL="12700">
+              <a:lnSpc>
+                <a:spcPct val="100000"/>
+              </a:lnSpc>
+              <a:spcBef>
+                <a:spcPts val="95"/>
+              </a:spcBef>
+            </a:pPr>
+            <a:r>
+              <a:rPr spc="-10" dirty="0"/>
+              <a:t>REAL-DATA PILOT &amp; SIGNAL STUDY</a:t>
+            </a:r>
+            <a:endParaRPr spc="-10" dirty="0"/>
+          </a:p>
+        </p:txBody>
+      </p:sp>
+      <p:sp>
+        <p:nvSpPr>
+          <p:cNvPr id="8" name="object 8"/>
+          <p:cNvSpPr txBox="1"/>
+          <p:nvPr/>
+        </p:nvSpPr>
+        <p:spPr>
+          <a:xfrm>
+            <a:off x="566928" y="6452870"/>
+            <a:ext cx="329184" cy="204470"/>
+          </a:xfrm>
+          <a:prstGeom prst="rect">
+            <a:avLst/>
+          </a:prstGeom>
+        </p:spPr>
+        <p:txBody>
+          <a:bodyPr vert="horz" wrap="none" lIns="0" tIns="0" rIns="0" bIns="0" rtlCol="0">
+            <a:spAutoFit/>
+          </a:bodyPr>
+          <a:lstStyle/>
+          <a:p>
+            <a:pPr marL="12700" algn="r">
+              <a:lnSpc>
+                <a:spcPts val="1435"/>
+              </a:lnSpc>
+            </a:pPr>
+            <a:r>
+              <a:rPr sz="1400" spc="-50" dirty="0">
+                <a:solidFill>
+                  <a:srgbClr val="404040"/>
+                </a:solidFill>
+                <a:latin typeface="Calibri"/>
+                <a:cs typeface="Calibri"/>
+              </a:rPr>
+              <a:t>11</a:t>
             </a:r>
           </a:p>
         </p:txBody>
@@ -11227,7 +12416,7 @@
 </p:sld>
 </file>
 
-<file path=ppt/slides/slide23.xml><?xml version="1.0" encoding="utf-8"?>
+<file path=ppt/slides/slide25.xml><?xml version="1.0" encoding="utf-8"?>
 <p:sld xmlns:a="http://schemas.openxmlformats.org/drawingml/2006/main" xmlns:r="http://schemas.openxmlformats.org/officeDocument/2006/relationships" xmlns:p="http://schemas.openxmlformats.org/presentationml/2006/main" showMasterSp="0">
   <p:cSld>
     <p:spTree>
@@ -11425,7 +12614,7 @@
                 <a:latin typeface="Calibri"/>
                 <a:cs typeface="Calibri"/>
               </a:rPr>
-              <a:t>10</a:t>
+              <a:t>12</a:t>
             </a:r>
           </a:p>
         </p:txBody>
@@ -12093,7 +13282,7 @@
 </p:sld>
 </file>
 
-<file path=ppt/slides/slide24.xml><?xml version="1.0" encoding="utf-8"?>
+<file path=ppt/slides/slide26.xml><?xml version="1.0" encoding="utf-8"?>
 <p:sld xmlns:a="http://schemas.openxmlformats.org/drawingml/2006/main" xmlns:r="http://schemas.openxmlformats.org/officeDocument/2006/relationships" xmlns:p="http://schemas.openxmlformats.org/presentationml/2006/main" showMasterSp="0">
   <p:cSld>
     <p:spTree>
@@ -12291,7 +13480,7 @@
                 <a:latin typeface="Calibri"/>
                 <a:cs typeface="Calibri"/>
               </a:rPr>
-              <a:t>11</a:t>
+              <a:t>13</a:t>
             </a:r>
           </a:p>
         </p:txBody>
@@ -13524,7 +14713,7 @@
                 </a:solidFill>
                 <a:latin typeface="Times New Roman"/>
               </a:rPr>
-              <a:t>Dashboard on Real Data</a:t>
+              <a:t>Website Walkthrough</a:t>
             </a:r>
           </a:p>
         </p:txBody>

</xml_diff>